<commit_message>
Richer deck: 7 slides with the why, the methods, and the tech stack
Added a 'problem' slide and a 'how it works' pipeline slide (Load, shared PCA, distances,
localize, drivers, interpret) with the actual methods (scPerturb energy distance + E-test,
MMD, Sinkhorn OT, Leiden + Fisher/BH, Wilcoxon DE). Put real numbers, the PubMed E-utilities
grounding, Claude's logged keep/skip verdict, and the scPerturb citation on the slides.
Updated SUBMISSION.md slide list to match; script lives in the speaker notes.

Co-Authored-By: Claude Opus 4.8 <noreply@anthropic.com>
</commit_message>
<xml_diff>
--- a/figures/shiftscope_deck.pptx
+++ b/figures/shiftscope_deck.pptx
@@ -11,6 +11,7 @@
     <p:sldId id="259" r:id="rId11"/>
     <p:sldId id="260" r:id="rId12"/>
     <p:sldId id="261" r:id="rId13"/>
+    <p:sldId id="262" r:id="rId14"/>
   </p:sldIdLst>
   <p:sldSz cx="12191695" cy="6858000" type="screen4x3"/>
   <p:notesSz cx="6858000" cy="9144000"/>
@@ -507,7 +508,7 @@
           <a:lstStyle/>
           <a:p>
             <a:r>
-              <a:t>This is ShiftScope. You give it two groups of cells and it tells you how they differ, where the difference is, which genes drive it, and what to test next.</a:t>
+              <a:t>This is ShiftScope. You give it two groups of cells, and it measures how they differ, shows where, finds the genes that drive it, and tells you what to test next.</a:t>
             </a:r>
           </a:p>
         </p:txBody>
@@ -577,7 +578,7 @@
           <a:lstStyle/>
           <a:p>
             <a:r>
-              <a:t>The same code runs on immune signaling, infection, blood development, and cell types, and gets the right biology each time. Interferon, antimicrobials, an erythroid program. Nothing is hard-coded to one disease.</a:t>
+              <a:t>Comparing two groups of cells is the most common question in the field, and it is done by hand. Two things stay hard. Is the difference real and how big, and which of many hits is actually worth testing.</a:t>
             </a:r>
           </a:p>
         </p:txBody>
@@ -647,7 +648,7 @@
           <a:lstStyle/>
           <a:p>
             <a:r>
-              <a:t>Here it is end to end on real data. Control versus interferon. A clear, strong shift, it lands in specific clusters, and the top genes are the known interferon response. Then Claude explains the biology, and every claim points back to a number we computed.</a:t>
+              <a:t>One PCA space for both groups. The main metric is the scPerturb energy distance with a permutation test, plus MMD and optimal transport as cross-checks. Leiden clustering with a Fisher test shows where the shift is, and Wilcoxon DE gives the driver genes.</a:t>
             </a:r>
           </a:p>
         </p:txBody>
@@ -717,7 +718,7 @@
           <a:lstStyle/>
           <a:p>
             <a:r>
-              <a:t>This is the part we think is most useful. On a real T-cell CRISPR screen, we rank hits by how strong they are and how little the gene has been studied. We count papers on PubMed, then Claude gives a keep-or-skip call using that count. Famous genes drop. Strong, under-studied genes rise to the top as things worth testing.</a:t>
+              <a:t>End to end on real data. Control versus interferon. E-distance 216, p 0.001. The stimulated cells form their own clusters, the drivers are the known interferon genes, and Claude explains it with every claim tied to a number.</a:t>
             </a:r>
           </a:p>
         </p:txBody>
@@ -787,7 +788,7 @@
           <a:lstStyle/>
           <a:p>
             <a:r>
-              <a:t>We are clear about limits. We checked where detection breaks, by cell number and by effect size. And the same ranking recovers a second real screen. The distance math follows the scPerturb standard.</a:t>
+              <a:t>The part we think matters most. On Marson's T-cell CRISPR screen, we rank hits by how strong they are and how little they have been studied. Novelty comes from a live PubMed count, and Claude gives a keep or skip call using that real number. Famous genes drop, strong and under-studied genes rise.</a:t>
             </a:r>
           </a:p>
         </p:txBody>
@@ -857,7 +858,77 @@
           <a:lstStyle/>
           <a:p>
             <a:r>
-              <a:t>ShiftScope turns 'these look different' into 'test this gene next.' Any two cell populations. It runs in Colab, it is open source. Thanks for watching.</a:t>
+              <a:t>We are clear about limits. We measured detection power by cell number and effect size, over many draws. It is validated across four domains and two real screens, and the distance math follows the scPerturb standard.</a:t>
+            </a:r>
+          </a:p>
+        </p:txBody>
+      </p:sp>
+      <p:sp>
+        <p:nvSpPr>
+          <p:cNvPr id="4" name="Slide Number Placeholder 3"/>
+          <p:cNvSpPr>
+            <a:spLocks noGrp="1"/>
+          </p:cNvSpPr>
+          <p:nvPr>
+            <p:ph type="sldNum" idx="5" sz="quarter"/>
+          </p:nvPr>
+        </p:nvSpPr>
+        <p:spPr/>
+      </p:sp>
+    </p:spTree>
+  </p:cSld>
+  <p:clrMapOvr>
+    <a:masterClrMapping/>
+  </p:clrMapOvr>
+</p:notes>
+</file>
+
+<file path=ppt/notesSlides/notesSlide7.xml><?xml version="1.0" encoding="utf-8"?>
+<p:notes xmlns:a="http://schemas.openxmlformats.org/drawingml/2006/main" xmlns:p="http://schemas.openxmlformats.org/presentationml/2006/main" xmlns:r="http://schemas.openxmlformats.org/officeDocument/2006/relationships">
+  <p:cSld>
+    <p:spTree>
+      <p:nvGrpSpPr>
+        <p:cNvPr id="1" name=""/>
+        <p:cNvGrpSpPr/>
+        <p:nvPr/>
+      </p:nvGrpSpPr>
+      <p:grpSpPr>
+        <a:xfrm>
+          <a:off x="0" y="0"/>
+          <a:ext cx="0" cy="0"/>
+          <a:chOff x="0" y="0"/>
+          <a:chExt cx="0" cy="0"/>
+        </a:xfrm>
+      </p:grpSpPr>
+      <p:sp>
+        <p:nvSpPr>
+          <p:cNvPr id="2" name="Slide Image Placeholder 1"/>
+          <p:cNvSpPr>
+            <a:spLocks noGrp="1"/>
+          </p:cNvSpPr>
+          <p:nvPr>
+            <p:ph type="sldImg" idx="2"/>
+          </p:nvPr>
+        </p:nvSpPr>
+        <p:spPr/>
+      </p:sp>
+      <p:sp>
+        <p:nvSpPr>
+          <p:cNvPr id="3" name="Notes Placeholder 2"/>
+          <p:cNvSpPr>
+            <a:spLocks noGrp="1"/>
+          </p:cNvSpPr>
+          <p:nvPr>
+            <p:ph type="body" idx="3" sz="quarter"/>
+          </p:nvPr>
+        </p:nvSpPr>
+        <p:spPr/>
+        <p:txBody>
+          <a:bodyPr/>
+          <a:lstStyle/>
+          <a:p>
+            <a:r>
+              <a:t>ShiftScope turns 'these look different' into 'test this gene next.' Any two cell populations, open source, runs in Colab. Thanks for watching.</a:t>
             </a:r>
           </a:p>
         </p:txBody>
@@ -3967,7 +4038,7 @@
         </p:nvSpPr>
         <p:spPr>
           <a:xfrm>
-            <a:off x="822960" y="2148840"/>
+            <a:off x="822960" y="2011680"/>
             <a:ext cx="7863840" cy="1097280"/>
           </a:xfrm>
           <a:prstGeom prst="rect">
@@ -3981,9 +4052,13 @@
           </a:bodyPr>
           <a:lstStyle/>
           <a:p>
-            <a:pPr algn="l"/>
-            <a:r>
-              <a:rPr sz="6000" b="1">
+            <a:pPr algn="l">
+              <a:spcAft>
+                <a:spcPts val="600"/>
+              </a:spcAft>
+            </a:pPr>
+            <a:r>
+              <a:rPr sz="5800" b="1" i="0">
                 <a:solidFill>
                   <a:srgbClr val="FFFFFF"/>
                 </a:solidFill>
@@ -4002,8 +4077,8 @@
         </p:nvSpPr>
         <p:spPr>
           <a:xfrm>
-            <a:off x="868680" y="3429000"/>
-            <a:ext cx="8412480" cy="1280160"/>
+            <a:off x="868680" y="3246120"/>
+            <a:ext cx="8046720" cy="1188720"/>
           </a:xfrm>
           <a:prstGeom prst="rect">
             <a:avLst/>
@@ -4016,15 +4091,19 @@
           </a:bodyPr>
           <a:lstStyle/>
           <a:p>
-            <a:pPr algn="l"/>
-            <a:r>
-              <a:rPr sz="2400" b="0">
+            <a:pPr algn="l">
+              <a:spcAft>
+                <a:spcPts val="600"/>
+              </a:spcAft>
+            </a:pPr>
+            <a:r>
+              <a:rPr sz="2200" b="0" i="0">
                 <a:solidFill>
                   <a:srgbClr val="02C39A"/>
                 </a:solidFill>
                 <a:latin typeface="Calibri"/>
               </a:rPr>
-              <a:t>Compare two groups of cells. See what changed, and what to test next.</a:t>
+              <a:t>Compare two groups of single cells. Measure the shift, find the drivers, and decide what to test next.</a:t>
             </a:r>
           </a:p>
         </p:txBody>
@@ -4037,8 +4116,8 @@
         </p:nvSpPr>
         <p:spPr>
           <a:xfrm>
-            <a:off x="868680" y="5989320"/>
-            <a:ext cx="9144000" cy="457200"/>
+            <a:off x="868680" y="5897880"/>
+            <a:ext cx="10058400" cy="548640"/>
           </a:xfrm>
           <a:prstGeom prst="rect">
             <a:avLst/>
@@ -4051,15 +4130,19 @@
           </a:bodyPr>
           <a:lstStyle/>
           <a:p>
-            <a:pPr algn="l"/>
-            <a:r>
-              <a:rPr sz="1400" b="0">
+            <a:pPr algn="l">
+              <a:spcAft>
+                <a:spcPts val="600"/>
+              </a:spcAft>
+            </a:pPr>
+            <a:r>
+              <a:rPr sz="1300" b="0" i="0">
                 <a:solidFill>
                   <a:srgbClr val="CADCFC"/>
                 </a:solidFill>
                 <a:latin typeface="Calibri"/>
               </a:rPr>
-              <a:t>Built with Claude: Life Sciences   ·   open source</a:t>
+              <a:t>Energy distance + optimal transport, differential expression, and grounded Claude prioritization.  Built with Claude: Life Sciences.</a:t>
             </a:r>
           </a:p>
         </p:txBody>
@@ -4098,8 +4181,8 @@
         </p:nvSpPr>
         <p:spPr>
           <a:xfrm>
-            <a:off x="822960" y="502920"/>
-            <a:ext cx="10515600" cy="822960"/>
+            <a:off x="822960" y="457200"/>
+            <a:ext cx="10698480" cy="868680"/>
           </a:xfrm>
           <a:prstGeom prst="rect">
             <a:avLst/>
@@ -4112,29 +4195,121 @@
           </a:bodyPr>
           <a:lstStyle/>
           <a:p>
-            <a:pPr algn="l"/>
-            <a:r>
-              <a:rPr sz="3800" b="1">
+            <a:pPr algn="l">
+              <a:spcAft>
+                <a:spcPts val="600"/>
+              </a:spcAft>
+            </a:pPr>
+            <a:r>
+              <a:rPr sz="3600" b="1" i="0">
                 <a:solidFill>
                   <a:srgbClr val="1A2B34"/>
                 </a:solidFill>
                 <a:latin typeface="Cambria"/>
               </a:rPr>
-              <a:t>One tool, many questions</a:t>
-            </a:r>
-          </a:p>
-        </p:txBody>
-      </p:sp>
-      <p:sp>
-        <p:nvSpPr>
-          <p:cNvPr id="3" name="TextBox 2"/>
+              <a:t>The problem</a:t>
+            </a:r>
+          </a:p>
+        </p:txBody>
+      </p:sp>
+      <p:sp>
+        <p:nvSpPr>
+          <p:cNvPr id="3" name="Oval 2"/>
+          <p:cNvSpPr/>
+          <p:nvPr/>
+        </p:nvSpPr>
+        <p:spPr>
+          <a:xfrm>
+            <a:off x="8869680" y="2926080"/>
+            <a:ext cx="2468880" cy="2468880"/>
+          </a:xfrm>
+          <a:prstGeom prst="ellipse">
+            <a:avLst/>
+          </a:prstGeom>
+          <a:noFill/>
+          <a:ln w="31750">
+            <a:solidFill>
+              <a:srgbClr val="028090"/>
+            </a:solidFill>
+          </a:ln>
+          <a:effectLst/>
+        </p:spPr>
+        <p:style>
+          <a:lnRef idx="1">
+            <a:schemeClr val="accent1"/>
+          </a:lnRef>
+          <a:fillRef idx="3">
+            <a:schemeClr val="accent1"/>
+          </a:fillRef>
+          <a:effectRef idx="2">
+            <a:schemeClr val="accent1"/>
+          </a:effectRef>
+          <a:fontRef idx="minor">
+            <a:schemeClr val="lt1"/>
+          </a:fontRef>
+        </p:style>
+        <p:txBody>
+          <a:bodyPr rtlCol="0" anchor="ctr"/>
+          <a:lstStyle/>
+          <a:p>
+            <a:pPr algn="ctr"/>
+          </a:p>
+        </p:txBody>
+      </p:sp>
+      <p:sp>
+        <p:nvSpPr>
+          <p:cNvPr id="4" name="Oval 3"/>
+          <p:cNvSpPr/>
+          <p:nvPr/>
+        </p:nvSpPr>
+        <p:spPr>
+          <a:xfrm>
+            <a:off x="10058400" y="2926080"/>
+            <a:ext cx="2468880" cy="2468880"/>
+          </a:xfrm>
+          <a:prstGeom prst="ellipse">
+            <a:avLst/>
+          </a:prstGeom>
+          <a:noFill/>
+          <a:ln w="31750">
+            <a:solidFill>
+              <a:srgbClr val="02C39A"/>
+            </a:solidFill>
+          </a:ln>
+          <a:effectLst/>
+        </p:spPr>
+        <p:style>
+          <a:lnRef idx="1">
+            <a:schemeClr val="accent1"/>
+          </a:lnRef>
+          <a:fillRef idx="3">
+            <a:schemeClr val="accent1"/>
+          </a:fillRef>
+          <a:effectRef idx="2">
+            <a:schemeClr val="accent1"/>
+          </a:effectRef>
+          <a:fontRef idx="minor">
+            <a:schemeClr val="lt1"/>
+          </a:fontRef>
+        </p:style>
+        <p:txBody>
+          <a:bodyPr rtlCol="0" anchor="ctr"/>
+          <a:lstStyle/>
+          <a:p>
+            <a:pPr algn="ctr"/>
+          </a:p>
+        </p:txBody>
+      </p:sp>
+      <p:sp>
+        <p:nvSpPr>
+          <p:cNvPr id="5" name="TextBox 4"/>
           <p:cNvSpPr txBox="1"/>
           <p:nvPr/>
         </p:nvSpPr>
         <p:spPr>
           <a:xfrm>
-            <a:off x="841248" y="1325880"/>
-            <a:ext cx="10515600" cy="548640"/>
+            <a:off x="822960" y="1508760"/>
+            <a:ext cx="7498079" cy="4480560"/>
           </a:xfrm>
           <a:prstGeom prst="rect">
             <a:avLst/>
@@ -4147,43 +4322,71 @@
           </a:bodyPr>
           <a:lstStyle/>
           <a:p>
-            <a:pPr algn="l"/>
-            <a:r>
-              <a:rPr sz="1600" b="0">
+            <a:pPr algn="l">
+              <a:spcAft>
+                <a:spcPts val="1600"/>
+              </a:spcAft>
+            </a:pPr>
+            <a:r>
+              <a:rPr sz="1700" b="0" i="0">
                 <a:solidFill>
                   <a:srgbClr val="5A6B73"/>
                 </a:solidFill>
                 <a:latin typeface="Calibri"/>
               </a:rPr>
-              <a:t>The same code runs across different biology and finds the right answer each time. Nothing is hard-coded to one disease.</a:t>
-            </a:r>
-          </a:p>
-        </p:txBody>
-      </p:sp>
-      <p:pic>
-        <p:nvPicPr>
-          <p:cNvPr id="4" name="Picture 3" descr="fig_domains.png"/>
-          <p:cNvPicPr>
-            <a:picLocks noChangeAspect="1"/>
-          </p:cNvPicPr>
-          <p:nvPr/>
-        </p:nvPicPr>
-        <p:blipFill>
-          <a:blip r:embed="rId2"/>
-          <a:stretch>
-            <a:fillRect/>
-          </a:stretch>
-        </p:blipFill>
-        <p:spPr>
-          <a:xfrm>
-            <a:off x="1234440" y="2057400"/>
-            <a:ext cx="9692640" cy="4581975"/>
-          </a:xfrm>
-          <a:prstGeom prst="rect">
-            <a:avLst/>
-          </a:prstGeom>
-        </p:spPr>
-      </p:pic>
+              <a:t>Comparing two cell populations is the most common question in single-cell work, and today it is mostly done by hand.</a:t>
+            </a:r>
+          </a:p>
+          <a:p>
+            <a:pPr algn="l">
+              <a:spcAft>
+                <a:spcPts val="1000"/>
+              </a:spcAft>
+            </a:pPr>
+            <a:r>
+              <a:rPr sz="1700" b="1" i="0">
+                <a:solidFill>
+                  <a:srgbClr val="1A2B34"/>
+                </a:solidFill>
+                <a:latin typeface="Calibri"/>
+              </a:rPr>
+              <a:t>Two things stay hard:</a:t>
+            </a:r>
+          </a:p>
+          <a:p>
+            <a:pPr algn="l">
+              <a:spcAft>
+                <a:spcPts val="1200"/>
+              </a:spcAft>
+            </a:pPr>
+            <a:r>
+              <a:rPr sz="1600" b="0" i="0">
+                <a:solidFill>
+                  <a:srgbClr val="1A2B34"/>
+                </a:solidFill>
+                <a:latin typeface="Calibri"/>
+              </a:rPr>
+              <a:t>1.  Is the difference real, and how big?  A UMAP cannot say, and a table of per-gene p-values does not give you one number for effect size.</a:t>
+            </a:r>
+          </a:p>
+          <a:p>
+            <a:pPr algn="l">
+              <a:spcAft>
+                <a:spcPts val="600"/>
+              </a:spcAft>
+            </a:pPr>
+            <a:r>
+              <a:rPr sz="1600" b="0" i="0">
+                <a:solidFill>
+                  <a:srgbClr val="1A2B34"/>
+                </a:solidFill>
+                <a:latin typeface="Calibri"/>
+              </a:rPr>
+              <a:t>2.  Of hundreds of screen hits, which deserve a month at the bench?  Ranking by effect size alone points you at genes everyone already knows.</a:t>
+            </a:r>
+          </a:p>
+        </p:txBody>
+      </p:sp>
     </p:spTree>
   </p:cSld>
   <p:clrMapOvr>
@@ -4218,8 +4421,8 @@
         </p:nvSpPr>
         <p:spPr>
           <a:xfrm>
-            <a:off x="822960" y="502920"/>
-            <a:ext cx="10972800" cy="822960"/>
+            <a:off x="822960" y="457200"/>
+            <a:ext cx="10698480" cy="868680"/>
           </a:xfrm>
           <a:prstGeom prst="rect">
             <a:avLst/>
@@ -4232,29 +4435,571 @@
           </a:bodyPr>
           <a:lstStyle/>
           <a:p>
-            <a:pPr algn="l"/>
-            <a:r>
-              <a:rPr sz="3800" b="1">
+            <a:pPr algn="l">
+              <a:spcAft>
+                <a:spcPts val="600"/>
+              </a:spcAft>
+            </a:pPr>
+            <a:r>
+              <a:rPr sz="3600" b="1" i="0">
                 <a:solidFill>
                   <a:srgbClr val="1A2B34"/>
                 </a:solidFill>
                 <a:latin typeface="Cambria"/>
               </a:rPr>
-              <a:t>One example, start to finish</a:t>
-            </a:r>
-          </a:p>
-        </p:txBody>
-      </p:sp>
-      <p:sp>
-        <p:nvSpPr>
-          <p:cNvPr id="3" name="TextBox 2"/>
+              <a:t>How it works</a:t>
+            </a:r>
+          </a:p>
+        </p:txBody>
+      </p:sp>
+      <p:sp>
+        <p:nvSpPr>
+          <p:cNvPr id="3" name="Rounded Rectangle 2"/>
+          <p:cNvSpPr/>
+          <p:nvPr/>
+        </p:nvSpPr>
+        <p:spPr>
+          <a:xfrm>
+            <a:off x="655167" y="1508760"/>
+            <a:ext cx="1554480" cy="749808"/>
+          </a:xfrm>
+          <a:prstGeom prst="roundRect">
+            <a:avLst/>
+          </a:prstGeom>
+          <a:solidFill>
+            <a:srgbClr val="028090"/>
+          </a:solidFill>
+          <a:ln>
+            <a:noFill/>
+          </a:ln>
+          <a:effectLst/>
+        </p:spPr>
+        <p:style>
+          <a:lnRef idx="1">
+            <a:schemeClr val="accent1"/>
+          </a:lnRef>
+          <a:fillRef idx="3">
+            <a:schemeClr val="accent1"/>
+          </a:fillRef>
+          <a:effectRef idx="2">
+            <a:schemeClr val="accent1"/>
+          </a:effectRef>
+          <a:fontRef idx="minor">
+            <a:schemeClr val="lt1"/>
+          </a:fontRef>
+        </p:style>
+        <p:txBody>
+          <a:bodyPr rtlCol="0" anchor="ctr" wrap="square"/>
+          <a:lstStyle/>
+          <a:p>
+            <a:pPr algn="ctr"/>
+            <a:r>
+              <a:rPr sz="1250" b="1">
+                <a:solidFill>
+                  <a:srgbClr val="FFFFFF"/>
+                </a:solidFill>
+                <a:latin typeface="Calibri"/>
+              </a:rPr>
+              <a:t>Load .h5ad</a:t>
+            </a:r>
+          </a:p>
+        </p:txBody>
+      </p:sp>
+      <p:sp>
+        <p:nvSpPr>
+          <p:cNvPr id="4" name="Right Arrow 3"/>
+          <p:cNvSpPr/>
+          <p:nvPr/>
+        </p:nvSpPr>
+        <p:spPr>
+          <a:xfrm>
+            <a:off x="2227935" y="1783080"/>
+            <a:ext cx="274320" cy="201168"/>
+          </a:xfrm>
+          <a:prstGeom prst="rightArrow">
+            <a:avLst/>
+          </a:prstGeom>
+          <a:solidFill>
+            <a:srgbClr val="02C39A"/>
+          </a:solidFill>
+          <a:ln>
+            <a:noFill/>
+          </a:ln>
+          <a:effectLst/>
+        </p:spPr>
+        <p:style>
+          <a:lnRef idx="1">
+            <a:schemeClr val="accent1"/>
+          </a:lnRef>
+          <a:fillRef idx="3">
+            <a:schemeClr val="accent1"/>
+          </a:fillRef>
+          <a:effectRef idx="2">
+            <a:schemeClr val="accent1"/>
+          </a:effectRef>
+          <a:fontRef idx="minor">
+            <a:schemeClr val="lt1"/>
+          </a:fontRef>
+        </p:style>
+        <p:txBody>
+          <a:bodyPr rtlCol="0" anchor="ctr"/>
+          <a:lstStyle/>
+          <a:p>
+            <a:pPr algn="ctr"/>
+          </a:p>
+        </p:txBody>
+      </p:sp>
+      <p:sp>
+        <p:nvSpPr>
+          <p:cNvPr id="5" name="Rounded Rectangle 4"/>
+          <p:cNvSpPr/>
+          <p:nvPr/>
+        </p:nvSpPr>
+        <p:spPr>
+          <a:xfrm>
+            <a:off x="2520543" y="1508760"/>
+            <a:ext cx="1554480" cy="749808"/>
+          </a:xfrm>
+          <a:prstGeom prst="roundRect">
+            <a:avLst/>
+          </a:prstGeom>
+          <a:solidFill>
+            <a:srgbClr val="028090"/>
+          </a:solidFill>
+          <a:ln>
+            <a:noFill/>
+          </a:ln>
+          <a:effectLst/>
+        </p:spPr>
+        <p:style>
+          <a:lnRef idx="1">
+            <a:schemeClr val="accent1"/>
+          </a:lnRef>
+          <a:fillRef idx="3">
+            <a:schemeClr val="accent1"/>
+          </a:fillRef>
+          <a:effectRef idx="2">
+            <a:schemeClr val="accent1"/>
+          </a:effectRef>
+          <a:fontRef idx="minor">
+            <a:schemeClr val="lt1"/>
+          </a:fontRef>
+        </p:style>
+        <p:txBody>
+          <a:bodyPr rtlCol="0" anchor="ctr" wrap="square"/>
+          <a:lstStyle/>
+          <a:p>
+            <a:pPr algn="ctr"/>
+            <a:r>
+              <a:rPr sz="1250" b="1">
+                <a:solidFill>
+                  <a:srgbClr val="FFFFFF"/>
+                </a:solidFill>
+                <a:latin typeface="Calibri"/>
+              </a:rPr>
+              <a:t>Shared PCA</a:t>
+            </a:r>
+          </a:p>
+        </p:txBody>
+      </p:sp>
+      <p:sp>
+        <p:nvSpPr>
+          <p:cNvPr id="6" name="Right Arrow 5"/>
+          <p:cNvSpPr/>
+          <p:nvPr/>
+        </p:nvSpPr>
+        <p:spPr>
+          <a:xfrm>
+            <a:off x="4093311" y="1783080"/>
+            <a:ext cx="274320" cy="201168"/>
+          </a:xfrm>
+          <a:prstGeom prst="rightArrow">
+            <a:avLst/>
+          </a:prstGeom>
+          <a:solidFill>
+            <a:srgbClr val="02C39A"/>
+          </a:solidFill>
+          <a:ln>
+            <a:noFill/>
+          </a:ln>
+          <a:effectLst/>
+        </p:spPr>
+        <p:style>
+          <a:lnRef idx="1">
+            <a:schemeClr val="accent1"/>
+          </a:lnRef>
+          <a:fillRef idx="3">
+            <a:schemeClr val="accent1"/>
+          </a:fillRef>
+          <a:effectRef idx="2">
+            <a:schemeClr val="accent1"/>
+          </a:effectRef>
+          <a:fontRef idx="minor">
+            <a:schemeClr val="lt1"/>
+          </a:fontRef>
+        </p:style>
+        <p:txBody>
+          <a:bodyPr rtlCol="0" anchor="ctr"/>
+          <a:lstStyle/>
+          <a:p>
+            <a:pPr algn="ctr"/>
+          </a:p>
+        </p:txBody>
+      </p:sp>
+      <p:sp>
+        <p:nvSpPr>
+          <p:cNvPr id="7" name="Rounded Rectangle 6"/>
+          <p:cNvSpPr/>
+          <p:nvPr/>
+        </p:nvSpPr>
+        <p:spPr>
+          <a:xfrm>
+            <a:off x="4385919" y="1508760"/>
+            <a:ext cx="1554480" cy="749808"/>
+          </a:xfrm>
+          <a:prstGeom prst="roundRect">
+            <a:avLst/>
+          </a:prstGeom>
+          <a:solidFill>
+            <a:srgbClr val="028090"/>
+          </a:solidFill>
+          <a:ln>
+            <a:noFill/>
+          </a:ln>
+          <a:effectLst/>
+        </p:spPr>
+        <p:style>
+          <a:lnRef idx="1">
+            <a:schemeClr val="accent1"/>
+          </a:lnRef>
+          <a:fillRef idx="3">
+            <a:schemeClr val="accent1"/>
+          </a:fillRef>
+          <a:effectRef idx="2">
+            <a:schemeClr val="accent1"/>
+          </a:effectRef>
+          <a:fontRef idx="minor">
+            <a:schemeClr val="lt1"/>
+          </a:fontRef>
+        </p:style>
+        <p:txBody>
+          <a:bodyPr rtlCol="0" anchor="ctr" wrap="square"/>
+          <a:lstStyle/>
+          <a:p>
+            <a:pPr algn="ctr"/>
+            <a:r>
+              <a:rPr sz="1250" b="1">
+                <a:solidFill>
+                  <a:srgbClr val="FFFFFF"/>
+                </a:solidFill>
+                <a:latin typeface="Calibri"/>
+              </a:rPr>
+              <a:t>Distances</a:t>
+            </a:r>
+          </a:p>
+        </p:txBody>
+      </p:sp>
+      <p:sp>
+        <p:nvSpPr>
+          <p:cNvPr id="8" name="Right Arrow 7"/>
+          <p:cNvSpPr/>
+          <p:nvPr/>
+        </p:nvSpPr>
+        <p:spPr>
+          <a:xfrm>
+            <a:off x="5958687" y="1783080"/>
+            <a:ext cx="274320" cy="201168"/>
+          </a:xfrm>
+          <a:prstGeom prst="rightArrow">
+            <a:avLst/>
+          </a:prstGeom>
+          <a:solidFill>
+            <a:srgbClr val="02C39A"/>
+          </a:solidFill>
+          <a:ln>
+            <a:noFill/>
+          </a:ln>
+          <a:effectLst/>
+        </p:spPr>
+        <p:style>
+          <a:lnRef idx="1">
+            <a:schemeClr val="accent1"/>
+          </a:lnRef>
+          <a:fillRef idx="3">
+            <a:schemeClr val="accent1"/>
+          </a:fillRef>
+          <a:effectRef idx="2">
+            <a:schemeClr val="accent1"/>
+          </a:effectRef>
+          <a:fontRef idx="minor">
+            <a:schemeClr val="lt1"/>
+          </a:fontRef>
+        </p:style>
+        <p:txBody>
+          <a:bodyPr rtlCol="0" anchor="ctr"/>
+          <a:lstStyle/>
+          <a:p>
+            <a:pPr algn="ctr"/>
+          </a:p>
+        </p:txBody>
+      </p:sp>
+      <p:sp>
+        <p:nvSpPr>
+          <p:cNvPr id="9" name="Rounded Rectangle 8"/>
+          <p:cNvSpPr/>
+          <p:nvPr/>
+        </p:nvSpPr>
+        <p:spPr>
+          <a:xfrm>
+            <a:off x="6251295" y="1508760"/>
+            <a:ext cx="1554480" cy="749808"/>
+          </a:xfrm>
+          <a:prstGeom prst="roundRect">
+            <a:avLst/>
+          </a:prstGeom>
+          <a:solidFill>
+            <a:srgbClr val="028090"/>
+          </a:solidFill>
+          <a:ln>
+            <a:noFill/>
+          </a:ln>
+          <a:effectLst/>
+        </p:spPr>
+        <p:style>
+          <a:lnRef idx="1">
+            <a:schemeClr val="accent1"/>
+          </a:lnRef>
+          <a:fillRef idx="3">
+            <a:schemeClr val="accent1"/>
+          </a:fillRef>
+          <a:effectRef idx="2">
+            <a:schemeClr val="accent1"/>
+          </a:effectRef>
+          <a:fontRef idx="minor">
+            <a:schemeClr val="lt1"/>
+          </a:fontRef>
+        </p:style>
+        <p:txBody>
+          <a:bodyPr rtlCol="0" anchor="ctr" wrap="square"/>
+          <a:lstStyle/>
+          <a:p>
+            <a:pPr algn="ctr"/>
+            <a:r>
+              <a:rPr sz="1250" b="1">
+                <a:solidFill>
+                  <a:srgbClr val="FFFFFF"/>
+                </a:solidFill>
+                <a:latin typeface="Calibri"/>
+              </a:rPr>
+              <a:t>Localize</a:t>
+            </a:r>
+          </a:p>
+        </p:txBody>
+      </p:sp>
+      <p:sp>
+        <p:nvSpPr>
+          <p:cNvPr id="10" name="Right Arrow 9"/>
+          <p:cNvSpPr/>
+          <p:nvPr/>
+        </p:nvSpPr>
+        <p:spPr>
+          <a:xfrm>
+            <a:off x="7824063" y="1783080"/>
+            <a:ext cx="274320" cy="201168"/>
+          </a:xfrm>
+          <a:prstGeom prst="rightArrow">
+            <a:avLst/>
+          </a:prstGeom>
+          <a:solidFill>
+            <a:srgbClr val="02C39A"/>
+          </a:solidFill>
+          <a:ln>
+            <a:noFill/>
+          </a:ln>
+          <a:effectLst/>
+        </p:spPr>
+        <p:style>
+          <a:lnRef idx="1">
+            <a:schemeClr val="accent1"/>
+          </a:lnRef>
+          <a:fillRef idx="3">
+            <a:schemeClr val="accent1"/>
+          </a:fillRef>
+          <a:effectRef idx="2">
+            <a:schemeClr val="accent1"/>
+          </a:effectRef>
+          <a:fontRef idx="minor">
+            <a:schemeClr val="lt1"/>
+          </a:fontRef>
+        </p:style>
+        <p:txBody>
+          <a:bodyPr rtlCol="0" anchor="ctr"/>
+          <a:lstStyle/>
+          <a:p>
+            <a:pPr algn="ctr"/>
+          </a:p>
+        </p:txBody>
+      </p:sp>
+      <p:sp>
+        <p:nvSpPr>
+          <p:cNvPr id="11" name="Rounded Rectangle 10"/>
+          <p:cNvSpPr/>
+          <p:nvPr/>
+        </p:nvSpPr>
+        <p:spPr>
+          <a:xfrm>
+            <a:off x="8116671" y="1508760"/>
+            <a:ext cx="1554480" cy="749808"/>
+          </a:xfrm>
+          <a:prstGeom prst="roundRect">
+            <a:avLst/>
+          </a:prstGeom>
+          <a:solidFill>
+            <a:srgbClr val="028090"/>
+          </a:solidFill>
+          <a:ln>
+            <a:noFill/>
+          </a:ln>
+          <a:effectLst/>
+        </p:spPr>
+        <p:style>
+          <a:lnRef idx="1">
+            <a:schemeClr val="accent1"/>
+          </a:lnRef>
+          <a:fillRef idx="3">
+            <a:schemeClr val="accent1"/>
+          </a:fillRef>
+          <a:effectRef idx="2">
+            <a:schemeClr val="accent1"/>
+          </a:effectRef>
+          <a:fontRef idx="minor">
+            <a:schemeClr val="lt1"/>
+          </a:fontRef>
+        </p:style>
+        <p:txBody>
+          <a:bodyPr rtlCol="0" anchor="ctr" wrap="square"/>
+          <a:lstStyle/>
+          <a:p>
+            <a:pPr algn="ctr"/>
+            <a:r>
+              <a:rPr sz="1250" b="1">
+                <a:solidFill>
+                  <a:srgbClr val="FFFFFF"/>
+                </a:solidFill>
+                <a:latin typeface="Calibri"/>
+              </a:rPr>
+              <a:t>Drivers</a:t>
+            </a:r>
+          </a:p>
+        </p:txBody>
+      </p:sp>
+      <p:sp>
+        <p:nvSpPr>
+          <p:cNvPr id="12" name="Right Arrow 11"/>
+          <p:cNvSpPr/>
+          <p:nvPr/>
+        </p:nvSpPr>
+        <p:spPr>
+          <a:xfrm>
+            <a:off x="9689439" y="1783080"/>
+            <a:ext cx="274320" cy="201168"/>
+          </a:xfrm>
+          <a:prstGeom prst="rightArrow">
+            <a:avLst/>
+          </a:prstGeom>
+          <a:solidFill>
+            <a:srgbClr val="02C39A"/>
+          </a:solidFill>
+          <a:ln>
+            <a:noFill/>
+          </a:ln>
+          <a:effectLst/>
+        </p:spPr>
+        <p:style>
+          <a:lnRef idx="1">
+            <a:schemeClr val="accent1"/>
+          </a:lnRef>
+          <a:fillRef idx="3">
+            <a:schemeClr val="accent1"/>
+          </a:fillRef>
+          <a:effectRef idx="2">
+            <a:schemeClr val="accent1"/>
+          </a:effectRef>
+          <a:fontRef idx="minor">
+            <a:schemeClr val="lt1"/>
+          </a:fontRef>
+        </p:style>
+        <p:txBody>
+          <a:bodyPr rtlCol="0" anchor="ctr"/>
+          <a:lstStyle/>
+          <a:p>
+            <a:pPr algn="ctr"/>
+          </a:p>
+        </p:txBody>
+      </p:sp>
+      <p:sp>
+        <p:nvSpPr>
+          <p:cNvPr id="13" name="Rounded Rectangle 12"/>
+          <p:cNvSpPr/>
+          <p:nvPr/>
+        </p:nvSpPr>
+        <p:spPr>
+          <a:xfrm>
+            <a:off x="9982047" y="1508760"/>
+            <a:ext cx="1554480" cy="749808"/>
+          </a:xfrm>
+          <a:prstGeom prst="roundRect">
+            <a:avLst/>
+          </a:prstGeom>
+          <a:solidFill>
+            <a:srgbClr val="028090"/>
+          </a:solidFill>
+          <a:ln>
+            <a:noFill/>
+          </a:ln>
+          <a:effectLst/>
+        </p:spPr>
+        <p:style>
+          <a:lnRef idx="1">
+            <a:schemeClr val="accent1"/>
+          </a:lnRef>
+          <a:fillRef idx="3">
+            <a:schemeClr val="accent1"/>
+          </a:fillRef>
+          <a:effectRef idx="2">
+            <a:schemeClr val="accent1"/>
+          </a:effectRef>
+          <a:fontRef idx="minor">
+            <a:schemeClr val="lt1"/>
+          </a:fontRef>
+        </p:style>
+        <p:txBody>
+          <a:bodyPr rtlCol="0" anchor="ctr" wrap="square"/>
+          <a:lstStyle/>
+          <a:p>
+            <a:pPr algn="ctr"/>
+            <a:r>
+              <a:rPr sz="1250" b="1">
+                <a:solidFill>
+                  <a:srgbClr val="FFFFFF"/>
+                </a:solidFill>
+                <a:latin typeface="Calibri"/>
+              </a:rPr>
+              <a:t>Interpret</a:t>
+            </a:r>
+          </a:p>
+        </p:txBody>
+      </p:sp>
+      <p:sp>
+        <p:nvSpPr>
+          <p:cNvPr id="14" name="TextBox 13"/>
           <p:cNvSpPr txBox="1"/>
           <p:nvPr/>
         </p:nvSpPr>
         <p:spPr>
           <a:xfrm>
-            <a:off x="822960" y="1600200"/>
-            <a:ext cx="4389120" cy="4206240"/>
+            <a:off x="822960" y="2788920"/>
+            <a:ext cx="5120640" cy="457200"/>
           </a:xfrm>
           <a:prstGeom prst="rect">
             <a:avLst/>
@@ -4269,105 +5014,138 @@
           <a:p>
             <a:pPr algn="l">
               <a:spcAft>
-                <a:spcPts val="1200"/>
+                <a:spcPts val="600"/>
               </a:spcAft>
             </a:pPr>
             <a:r>
-              <a:rPr sz="1800" b="1">
+              <a:rPr sz="1800" b="1" i="0">
                 <a:solidFill>
                   <a:srgbClr val="028090"/>
                 </a:solidFill>
                 <a:latin typeface="Calibri"/>
               </a:rPr>
-              <a:t>Control vs interferon, in monocytes.</a:t>
-            </a:r>
-          </a:p>
+              <a:t>Measuring the shift</a:t>
+            </a:r>
+          </a:p>
+        </p:txBody>
+      </p:sp>
+      <p:sp>
+        <p:nvSpPr>
+          <p:cNvPr id="15" name="TextBox 14"/>
+          <p:cNvSpPr txBox="1"/>
+          <p:nvPr/>
+        </p:nvSpPr>
+        <p:spPr>
+          <a:xfrm>
+            <a:off x="822960" y="3291840"/>
+            <a:ext cx="5120640" cy="3108960"/>
+          </a:xfrm>
+          <a:prstGeom prst="rect">
+            <a:avLst/>
+          </a:prstGeom>
+          <a:noFill/>
+        </p:spPr>
+        <p:txBody>
+          <a:bodyPr wrap="square" anchor="t">
+            <a:spAutoFit/>
+          </a:bodyPr>
+          <a:lstStyle/>
           <a:p>
             <a:pPr algn="l">
               <a:spcAft>
-                <a:spcPts val="1000"/>
+                <a:spcPts val="600"/>
               </a:spcAft>
             </a:pPr>
             <a:r>
-              <a:rPr sz="1600" b="0">
+              <a:rPr sz="1450" b="0" i="0">
                 <a:solidFill>
                   <a:srgbClr val="1A2B34"/>
                 </a:solidFill>
                 <a:latin typeface="Calibri"/>
               </a:rPr>
-              <a:t>•  A clear shift: E-distance 216, p = 0.001</a:t>
-            </a:r>
-          </a:p>
+              <a:t>Everything runs in one PCA space fit on the pooled cells, so the two groups are comparable. The headline metric is the scPerturb energy distance (E-distance), with a label-permutation E-test for significance. MMD (RBF kernel) and Sinkhorn optimal transport (POT) are reported as geometry-aware cross-checks.</a:t>
+            </a:r>
+          </a:p>
+        </p:txBody>
+      </p:sp>
+      <p:sp>
+        <p:nvSpPr>
+          <p:cNvPr id="16" name="TextBox 15"/>
+          <p:cNvSpPr txBox="1"/>
+          <p:nvPr/>
+        </p:nvSpPr>
+        <p:spPr>
+          <a:xfrm>
+            <a:off x="6400800" y="2788920"/>
+            <a:ext cx="5120640" cy="457200"/>
+          </a:xfrm>
+          <a:prstGeom prst="rect">
+            <a:avLst/>
+          </a:prstGeom>
+          <a:noFill/>
+        </p:spPr>
+        <p:txBody>
+          <a:bodyPr wrap="square" anchor="t">
+            <a:spAutoFit/>
+          </a:bodyPr>
+          <a:lstStyle/>
           <a:p>
             <a:pPr algn="l">
               <a:spcAft>
-                <a:spcPts val="1000"/>
+                <a:spcPts val="600"/>
               </a:spcAft>
             </a:pPr>
             <a:r>
-              <a:rPr sz="1600" b="0">
+              <a:rPr sz="1800" b="1" i="0">
+                <a:solidFill>
+                  <a:srgbClr val="028090"/>
+                </a:solidFill>
+                <a:latin typeface="Calibri"/>
+              </a:rPr>
+              <a:t>Where, and what drives it</a:t>
+            </a:r>
+          </a:p>
+        </p:txBody>
+      </p:sp>
+      <p:sp>
+        <p:nvSpPr>
+          <p:cNvPr id="17" name="TextBox 16"/>
+          <p:cNvSpPr txBox="1"/>
+          <p:nvPr/>
+        </p:nvSpPr>
+        <p:spPr>
+          <a:xfrm>
+            <a:off x="6400800" y="3291840"/>
+            <a:ext cx="5120640" cy="3108960"/>
+          </a:xfrm>
+          <a:prstGeom prst="rect">
+            <a:avLst/>
+          </a:prstGeom>
+          <a:noFill/>
+        </p:spPr>
+        <p:txBody>
+          <a:bodyPr wrap="square" anchor="t">
+            <a:spAutoFit/>
+          </a:bodyPr>
+          <a:lstStyle/>
+          <a:p>
+            <a:pPr algn="l">
+              <a:spcAft>
+                <a:spcPts val="600"/>
+              </a:spcAft>
+            </a:pPr>
+            <a:r>
+              <a:rPr sz="1450" b="0" i="0">
                 <a:solidFill>
                   <a:srgbClr val="1A2B34"/>
                 </a:solidFill>
                 <a:latin typeface="Calibri"/>
               </a:rPr>
-              <a:t>•  It lands in specific clusters</a:t>
-            </a:r>
-          </a:p>
-          <a:p>
-            <a:pPr algn="l">
-              <a:spcAft>
-                <a:spcPts val="1000"/>
-              </a:spcAft>
-            </a:pPr>
-            <a:r>
-              <a:rPr sz="1600" b="0">
-                <a:solidFill>
-                  <a:srgbClr val="1A2B34"/>
-                </a:solidFill>
-                <a:latin typeface="Calibri"/>
-              </a:rPr>
-              <a:t>•  Top genes are the known interferon response (ISG15, MX1, OAS1)</a:t>
-            </a:r>
-          </a:p>
-          <a:p>
-            <a:pPr algn="l"/>
-            <a:r>
-              <a:rPr sz="1600" b="0">
-                <a:solidFill>
-                  <a:srgbClr val="1A2B34"/>
-                </a:solidFill>
-                <a:latin typeface="Calibri"/>
-              </a:rPr>
-              <a:t>•  Then Claude explains it, and every claim points to a number we computed</a:t>
-            </a:r>
-          </a:p>
-        </p:txBody>
-      </p:sp>
-      <p:pic>
-        <p:nvPicPr>
-          <p:cNvPr id="4" name="Picture 3" descr="fig_kang_umap.png"/>
-          <p:cNvPicPr>
-            <a:picLocks noChangeAspect="1"/>
-          </p:cNvPicPr>
-          <p:nvPr/>
-        </p:nvPicPr>
-        <p:blipFill>
-          <a:blip r:embed="rId2"/>
-          <a:stretch>
-            <a:fillRect/>
-          </a:stretch>
-        </p:blipFill>
-        <p:spPr>
-          <a:xfrm>
-            <a:off x="5074920" y="2331720"/>
-            <a:ext cx="6675120" cy="2791413"/>
-          </a:xfrm>
-          <a:prstGeom prst="rect">
-            <a:avLst/>
-          </a:prstGeom>
-        </p:spPr>
-      </p:pic>
+              <a:t>Leiden clusters the shared latent; a per-cluster Fisher exact test with Benjamini-Hochberg correction flags the clusters that gained or lost query cells. Wilcoxon rank-sum DE inside those clusters gives the driver genes, ranked by the Wilcoxon score among significant hits.</a:t>
+            </a:r>
+          </a:p>
+        </p:txBody>
+      </p:sp>
     </p:spTree>
   </p:cSld>
   <p:clrMapOvr>
@@ -4402,8 +5180,8 @@
         </p:nvSpPr>
         <p:spPr>
           <a:xfrm>
-            <a:off x="822960" y="502920"/>
-            <a:ext cx="10972800" cy="822960"/>
+            <a:off x="822960" y="457200"/>
+            <a:ext cx="10698480" cy="868680"/>
           </a:xfrm>
           <a:prstGeom prst="rect">
             <a:avLst/>
@@ -4416,15 +5194,19 @@
           </a:bodyPr>
           <a:lstStyle/>
           <a:p>
-            <a:pPr algn="l"/>
-            <a:r>
-              <a:rPr sz="3600" b="1">
+            <a:pPr algn="l">
+              <a:spcAft>
+                <a:spcPts val="600"/>
+              </a:spcAft>
+            </a:pPr>
+            <a:r>
+              <a:rPr sz="3600" b="1" i="0">
                 <a:solidFill>
                   <a:srgbClr val="1A2B34"/>
                 </a:solidFill>
                 <a:latin typeface="Cambria"/>
               </a:rPr>
-              <a:t>The useful part: what to test next</a:t>
+              <a:t>One example, end to end</a:t>
             </a:r>
           </a:p>
         </p:txBody>
@@ -4438,7 +5220,7 @@
         <p:spPr>
           <a:xfrm>
             <a:off x="822960" y="1554480"/>
-            <a:ext cx="6035040" cy="4389120"/>
+            <a:ext cx="4480560" cy="4480560"/>
           </a:xfrm>
           <a:prstGeom prst="rect">
             <a:avLst/>
@@ -4457,80 +5239,84 @@
               </a:spcAft>
             </a:pPr>
             <a:r>
-              <a:rPr sz="1800" b="1">
+              <a:rPr sz="1700" b="1" i="0">
                 <a:solidFill>
                   <a:srgbClr val="028090"/>
                 </a:solidFill>
                 <a:latin typeface="Calibri"/>
               </a:rPr>
-              <a:t>On a real T-cell CRISPR screen (Marson lab):</a:t>
+              <a:t>Control vs IFN-β, CD14+ monocytes (Kang 2018).</a:t>
             </a:r>
           </a:p>
           <a:p>
             <a:pPr algn="l">
               <a:spcAft>
-                <a:spcPts val="1000"/>
+                <a:spcPts val="900"/>
               </a:spcAft>
             </a:pPr>
             <a:r>
-              <a:rPr sz="1600" b="0">
+              <a:rPr sz="1550" b="0" i="0">
                 <a:solidFill>
                   <a:srgbClr val="1A2B34"/>
                 </a:solidFill>
                 <a:latin typeface="Calibri"/>
               </a:rPr>
-              <a:t>•  Rank hits by how strong they are and how little they've been studied</a:t>
+              <a:t>•  E-distance 216, permutation p = 0.001. MMD and Sinkhorn agree.</a:t>
             </a:r>
           </a:p>
           <a:p>
             <a:pPr algn="l">
               <a:spcAft>
-                <a:spcPts val="1000"/>
+                <a:spcPts val="900"/>
               </a:spcAft>
             </a:pPr>
             <a:r>
-              <a:rPr sz="1600" b="0">
+              <a:rPr sz="1550" b="0" i="0">
                 <a:solidFill>
                   <a:srgbClr val="1A2B34"/>
                 </a:solidFill>
                 <a:latin typeface="Calibri"/>
               </a:rPr>
-              <a:t>•  Novelty comes from a live PubMed paper count, not a guess</a:t>
+              <a:t>•  Leiden + Fisher/BH: the stimulated cells form their own clusters (log2 enrichment up to +9).</a:t>
             </a:r>
           </a:p>
           <a:p>
             <a:pPr algn="l">
               <a:spcAft>
-                <a:spcPts val="1000"/>
+                <a:spcPts val="900"/>
               </a:spcAft>
             </a:pPr>
             <a:r>
-              <a:rPr sz="1600" b="0">
+              <a:rPr sz="1550" b="0" i="0">
                 <a:solidFill>
                   <a:srgbClr val="1A2B34"/>
                 </a:solidFill>
                 <a:latin typeface="Calibri"/>
               </a:rPr>
-              <a:t>•  Claude gives a keep-or-skip call using that real count</a:t>
-            </a:r>
-          </a:p>
-          <a:p>
-            <a:pPr algn="l"/>
-            <a:r>
-              <a:rPr sz="1600" b="0">
+              <a:t>•  Wilcoxon drivers: ISG15, MX1, IFIT1/3, OAS1, the type-I interferon program.</a:t>
+            </a:r>
+          </a:p>
+          <a:p>
+            <a:pPr algn="l">
+              <a:spcAft>
+                <a:spcPts val="600"/>
+              </a:spcAft>
+            </a:pPr>
+            <a:r>
+              <a:rPr sz="1550" b="0" i="0">
                 <a:solidFill>
                   <a:srgbClr val="1A2B34"/>
                 </a:solidFill>
                 <a:latin typeface="Calibri"/>
               </a:rPr>
-              <a:t>•  Famous genes (VAV1, CD45) drop. Strong, under-studied genes rise to the top.</a:t>
+              <a:t>•  Claude writes a short rationale, and every claim cites one of these numbers. The exact prompt and evidence are logged.</a:t>
             </a:r>
           </a:p>
         </p:txBody>
       </p:sp>
       <p:pic>
         <p:nvPicPr>
-          <p:cNvPr id="4" name="Picture 3" descr="fig_prioritize.png"/>
+          <p:cNvPr id="4" name="Picture 3" descr="fig_kang_umap.png"/>
           <p:cNvPicPr>
             <a:picLocks noChangeAspect="1"/>
           </p:cNvPicPr>
@@ -4544,8 +5330,8 @@
         </p:blipFill>
         <p:spPr>
           <a:xfrm>
-            <a:off x="7086600" y="2148840"/>
-            <a:ext cx="4572000" cy="3429000"/>
+            <a:off x="5394960" y="2514600"/>
+            <a:ext cx="6309360" cy="2638459"/>
           </a:xfrm>
           <a:prstGeom prst="rect">
             <a:avLst/>
@@ -4586,8 +5372,8 @@
         </p:nvSpPr>
         <p:spPr>
           <a:xfrm>
-            <a:off x="822960" y="502920"/>
-            <a:ext cx="10972800" cy="822960"/>
+            <a:off x="822960" y="457200"/>
+            <a:ext cx="10698480" cy="868680"/>
           </a:xfrm>
           <a:prstGeom prst="rect">
             <a:avLst/>
@@ -4600,9 +5386,205 @@
           </a:bodyPr>
           <a:lstStyle/>
           <a:p>
-            <a:pPr algn="l"/>
-            <a:r>
-              <a:rPr sz="3800" b="1">
+            <a:pPr algn="l">
+              <a:spcAft>
+                <a:spcPts val="600"/>
+              </a:spcAft>
+            </a:pPr>
+            <a:r>
+              <a:rPr sz="3200" b="1" i="0">
+                <a:solidFill>
+                  <a:srgbClr val="1A2B34"/>
+                </a:solidFill>
+                <a:latin typeface="Cambria"/>
+              </a:rPr>
+              <a:t>From metric to decision: what to test next</a:t>
+            </a:r>
+          </a:p>
+        </p:txBody>
+      </p:sp>
+      <p:sp>
+        <p:nvSpPr>
+          <p:cNvPr id="3" name="TextBox 2"/>
+          <p:cNvSpPr txBox="1"/>
+          <p:nvPr/>
+        </p:nvSpPr>
+        <p:spPr>
+          <a:xfrm>
+            <a:off x="822960" y="1417320"/>
+            <a:ext cx="6126480" cy="4572000"/>
+          </a:xfrm>
+          <a:prstGeom prst="rect">
+            <a:avLst/>
+          </a:prstGeom>
+          <a:noFill/>
+        </p:spPr>
+        <p:txBody>
+          <a:bodyPr wrap="square" anchor="t">
+            <a:spAutoFit/>
+          </a:bodyPr>
+          <a:lstStyle/>
+          <a:p>
+            <a:pPr algn="l">
+              <a:spcAft>
+                <a:spcPts val="1100"/>
+              </a:spcAft>
+            </a:pPr>
+            <a:r>
+              <a:rPr sz="1600" b="1" i="0">
+                <a:solidFill>
+                  <a:srgbClr val="028090"/>
+                </a:solidFill>
+                <a:latin typeface="Calibri"/>
+              </a:rPr>
+              <a:t>On Marson's genome-scale CD4+ T-cell CRISPR screen (~11k knockouts):</a:t>
+            </a:r>
+          </a:p>
+          <a:p>
+            <a:pPr algn="l">
+              <a:spcAft>
+                <a:spcPts val="900"/>
+              </a:spcAft>
+            </a:pPr>
+            <a:r>
+              <a:rPr sz="1500" b="0" i="0">
+                <a:solidFill>
+                  <a:srgbClr val="1A2B34"/>
+                </a:solidFill>
+                <a:latin typeface="Calibri"/>
+              </a:rPr>
+              <a:t>•  Phenotype strength = number of downstream DE genes per knockout.</a:t>
+            </a:r>
+          </a:p>
+          <a:p>
+            <a:pPr algn="l">
+              <a:spcAft>
+                <a:spcPts val="900"/>
+              </a:spcAft>
+            </a:pPr>
+            <a:r>
+              <a:rPr sz="1500" b="0" i="0">
+                <a:solidFill>
+                  <a:srgbClr val="1A2B34"/>
+                </a:solidFill>
+                <a:latin typeface="Calibri"/>
+              </a:rPr>
+              <a:t>•  Novelty is grounded, not guessed: a live NCBI PubMed count (E-utilities) of papers on each gene in an immune context. Cached and rate-limited.</a:t>
+            </a:r>
+          </a:p>
+          <a:p>
+            <a:pPr algn="l">
+              <a:spcAft>
+                <a:spcPts val="900"/>
+              </a:spcAft>
+            </a:pPr>
+            <a:r>
+              <a:rPr sz="1500" b="0" i="0">
+                <a:solidFill>
+                  <a:srgbClr val="1A2B34"/>
+                </a:solidFill>
+                <a:latin typeface="Calibri"/>
+              </a:rPr>
+              <a:t>•  Claude scores novelty 1–5 and gives a keep/skip verdict with that real count in front of it. Prompt + evidence logged for every call.</a:t>
+            </a:r>
+          </a:p>
+          <a:p>
+            <a:pPr algn="l">
+              <a:spcAft>
+                <a:spcPts val="600"/>
+              </a:spcAft>
+            </a:pPr>
+            <a:r>
+              <a:rPr sz="1500" b="0" i="0">
+                <a:solidFill>
+                  <a:srgbClr val="1A2B34"/>
+                </a:solidFill>
+                <a:latin typeface="Calibri"/>
+              </a:rPr>
+              <a:t>•  VAV1, CD45 (hundreds of papers) drop. Strong but obscure SAGA-complex genes (TADA2B, SGF29, ELOF1; 0–4 papers) rise to the top.</a:t>
+            </a:r>
+          </a:p>
+        </p:txBody>
+      </p:sp>
+      <p:pic>
+        <p:nvPicPr>
+          <p:cNvPr id="4" name="Picture 3" descr="fig_prioritize.png"/>
+          <p:cNvPicPr>
+            <a:picLocks noChangeAspect="1"/>
+          </p:cNvPicPr>
+          <p:nvPr/>
+        </p:nvPicPr>
+        <p:blipFill>
+          <a:blip r:embed="rId2"/>
+          <a:stretch>
+            <a:fillRect/>
+          </a:stretch>
+        </p:blipFill>
+        <p:spPr>
+          <a:xfrm>
+            <a:off x="7223760" y="2057400"/>
+            <a:ext cx="4480560" cy="3360420"/>
+          </a:xfrm>
+          <a:prstGeom prst="rect">
+            <a:avLst/>
+          </a:prstGeom>
+        </p:spPr>
+      </p:pic>
+    </p:spTree>
+  </p:cSld>
+  <p:clrMapOvr>
+    <a:masterClrMapping/>
+  </p:clrMapOvr>
+</p:sld>
+</file>
+
+<file path=ppt/slides/slide6.xml><?xml version="1.0" encoding="utf-8"?>
+<p:sld xmlns:a="http://schemas.openxmlformats.org/drawingml/2006/main" xmlns:p="http://schemas.openxmlformats.org/presentationml/2006/main" xmlns:r="http://schemas.openxmlformats.org/officeDocument/2006/relationships">
+  <p:cSld>
+    <p:bg>
+      <p:bgPr>
+        <a:solidFill>
+          <a:srgbClr val="FFFFFF"/>
+        </a:solidFill>
+        <a:effectLst/>
+      </p:bgPr>
+    </p:bg>
+    <p:spTree>
+      <p:nvGrpSpPr>
+        <p:cNvPr id="1" name=""/>
+        <p:cNvGrpSpPr/>
+        <p:nvPr/>
+      </p:nvGrpSpPr>
+      <p:grpSpPr/>
+      <p:sp>
+        <p:nvSpPr>
+          <p:cNvPr id="2" name="TextBox 1"/>
+          <p:cNvSpPr txBox="1"/>
+          <p:nvPr/>
+        </p:nvSpPr>
+        <p:spPr>
+          <a:xfrm>
+            <a:off x="822960" y="457200"/>
+            <a:ext cx="10698480" cy="868680"/>
+          </a:xfrm>
+          <a:prstGeom prst="rect">
+            <a:avLst/>
+          </a:prstGeom>
+          <a:noFill/>
+        </p:spPr>
+        <p:txBody>
+          <a:bodyPr wrap="square" anchor="t">
+            <a:spAutoFit/>
+          </a:bodyPr>
+          <a:lstStyle/>
+          <a:p>
+            <a:pPr algn="l">
+              <a:spcAft>
+                <a:spcPts val="600"/>
+              </a:spcAft>
+            </a:pPr>
+            <a:r>
+              <a:rPr sz="3600" b="1" i="0">
                 <a:solidFill>
                   <a:srgbClr val="1A2B34"/>
                 </a:solidFill>
@@ -4629,8 +5611,8 @@
         </p:blipFill>
         <p:spPr>
           <a:xfrm>
-            <a:off x="822960" y="1965960"/>
-            <a:ext cx="5669280" cy="3968496"/>
+            <a:off x="822960" y="1874519"/>
+            <a:ext cx="5577840" cy="3904487"/>
           </a:xfrm>
           <a:prstGeom prst="rect">
             <a:avLst/>
@@ -4645,8 +5627,8 @@
         </p:nvSpPr>
         <p:spPr>
           <a:xfrm>
-            <a:off x="6766560" y="2011680"/>
-            <a:ext cx="4937760" cy="4206240"/>
+            <a:off x="6675120" y="1783080"/>
+            <a:ext cx="5029200" cy="4389120"/>
           </a:xfrm>
           <a:prstGeom prst="rect">
             <a:avLst/>
@@ -4665,73 +5647,77 @@
               </a:spcAft>
             </a:pPr>
             <a:r>
-              <a:rPr sz="1800" b="1">
+              <a:rPr sz="1800" b="1" i="0">
                 <a:solidFill>
                   <a:srgbClr val="028090"/>
                 </a:solidFill>
                 <a:latin typeface="Calibri"/>
               </a:rPr>
-              <a:t>We checked where it stops working.</a:t>
+              <a:t>We measured where it breaks.</a:t>
             </a:r>
           </a:p>
           <a:p>
             <a:pPr algn="l">
               <a:spcAft>
-                <a:spcPts val="1000"/>
+                <a:spcPts val="900"/>
               </a:spcAft>
             </a:pPr>
             <a:r>
-              <a:rPr sz="1600" b="0">
+              <a:rPr sz="1500" b="0" i="0">
                 <a:solidFill>
                   <a:srgbClr val="1A2B34"/>
                 </a:solidFill>
                 <a:latin typeface="Calibri"/>
               </a:rPr>
-              <a:t>•  Tested detection by cell number and by effect size</a:t>
+              <a:t>•  Detection power over many random draws, not one lucky p-value.</a:t>
             </a:r>
           </a:p>
           <a:p>
             <a:pPr algn="l">
               <a:spcAft>
-                <a:spcPts val="1000"/>
+                <a:spcPts val="900"/>
               </a:spcAft>
             </a:pPr>
             <a:r>
-              <a:rPr sz="1600" b="0">
+              <a:rPr sz="1500" b="0" i="0">
                 <a:solidFill>
                   <a:srgbClr val="1A2B34"/>
                 </a:solidFill>
                 <a:latin typeface="Calibri"/>
               </a:rPr>
-              <a:t>•  Needs about 100 cells per group for a subtle shift</a:t>
+              <a:t>•  Needs about 100 cells per group for a subtle shift; detects a shift until it is diluted below ~10% of its true size.</a:t>
             </a:r>
           </a:p>
           <a:p>
             <a:pPr algn="l">
               <a:spcAft>
-                <a:spcPts val="1000"/>
+                <a:spcPts val="900"/>
               </a:spcAft>
             </a:pPr>
             <a:r>
-              <a:rPr sz="1600" b="0">
+              <a:rPr sz="1500" b="0" i="0">
                 <a:solidFill>
                   <a:srgbClr val="1A2B34"/>
                 </a:solidFill>
                 <a:latin typeface="Calibri"/>
               </a:rPr>
-              <a:t>•  The same ranking recovers a second real screen (Shifrut)</a:t>
-            </a:r>
-          </a:p>
-          <a:p>
-            <a:pPr algn="l"/>
-            <a:r>
-              <a:rPr sz="1600" b="0">
+              <a:t>•  Validated across four domains (immune, infection, development, cell type) and two real CRISPR screens (Marson, Shifrut), correct distinct biology each time.</a:t>
+            </a:r>
+          </a:p>
+          <a:p>
+            <a:pPr algn="l">
+              <a:spcAft>
+                <a:spcPts val="600"/>
+              </a:spcAft>
+            </a:pPr>
+            <a:r>
+              <a:rPr sz="1500" b="0" i="0">
                 <a:solidFill>
                   <a:srgbClr val="1A2B34"/>
                 </a:solidFill>
                 <a:latin typeface="Calibri"/>
               </a:rPr>
-              <a:t>•  Math matches the field standard (scPerturb E-distance)</a:t>
+              <a:t>•  Distances follow the scPerturb standard (Peidli et al., Nat. Methods 2024).</a:t>
             </a:r>
           </a:p>
         </p:txBody>
@@ -4744,7 +5730,7 @@
 </p:sld>
 </file>
 
-<file path=ppt/slides/slide6.xml><?xml version="1.0" encoding="utf-8"?>
+<file path=ppt/slides/slide7.xml><?xml version="1.0" encoding="utf-8"?>
 <p:sld xmlns:a="http://schemas.openxmlformats.org/drawingml/2006/main" xmlns:p="http://schemas.openxmlformats.org/presentationml/2006/main" xmlns:r="http://schemas.openxmlformats.org/officeDocument/2006/relationships">
   <p:cSld>
     <p:bg>
@@ -4858,7 +5844,7 @@
         </p:nvSpPr>
         <p:spPr>
           <a:xfrm>
-            <a:off x="822960" y="1965960"/>
+            <a:off x="822960" y="1874519"/>
             <a:ext cx="10515600" cy="1645920"/>
           </a:xfrm>
           <a:prstGeom prst="rect">
@@ -4872,9 +5858,13 @@
           </a:bodyPr>
           <a:lstStyle/>
           <a:p>
-            <a:pPr algn="l"/>
-            <a:r>
-              <a:rPr sz="3600" b="1">
+            <a:pPr algn="l">
+              <a:spcAft>
+                <a:spcPts val="600"/>
+              </a:spcAft>
+            </a:pPr>
+            <a:r>
+              <a:rPr sz="3400" b="1" i="0">
                 <a:solidFill>
                   <a:srgbClr val="FFFFFF"/>
                 </a:solidFill>
@@ -4893,7 +5883,7 @@
         </p:nvSpPr>
         <p:spPr>
           <a:xfrm>
-            <a:off x="868680" y="3611880"/>
+            <a:off x="868680" y="3429000"/>
             <a:ext cx="10058400" cy="640080"/>
           </a:xfrm>
           <a:prstGeom prst="rect">
@@ -4907,15 +5897,19 @@
           </a:bodyPr>
           <a:lstStyle/>
           <a:p>
-            <a:pPr algn="l"/>
-            <a:r>
-              <a:rPr sz="2000" b="0">
+            <a:pPr algn="l">
+              <a:spcAft>
+                <a:spcPts val="600"/>
+              </a:spcAft>
+            </a:pPr>
+            <a:r>
+              <a:rPr sz="1800" b="0" i="0">
                 <a:solidFill>
                   <a:srgbClr val="02C39A"/>
                 </a:solidFill>
                 <a:latin typeface="Calibri"/>
               </a:rPr>
-              <a:t>Any two cell populations. Runs in Colab. Open source (MIT).</a:t>
+              <a:t>Any two cell populations. Python, scanpy, POT, NCBI E-utilities, Claude (Anthropic SDK). Runs in Colab. MIT.</a:t>
             </a:r>
           </a:p>
         </p:txBody>
@@ -4942,9 +5936,13 @@
           </a:bodyPr>
           <a:lstStyle/>
           <a:p>
-            <a:pPr algn="l"/>
-            <a:r>
-              <a:rPr sz="1500" b="0">
+            <a:pPr algn="l">
+              <a:spcAft>
+                <a:spcPts val="600"/>
+              </a:spcAft>
+            </a:pPr>
+            <a:r>
+              <a:rPr sz="1500" b="0" i="0">
                 <a:solidFill>
                   <a:srgbClr val="CADCFC"/>
                 </a:solidFill>

</xml_diff>